<commit_message>
2026-08-26: Complete Geti CSAM Helper agent and skills package; update project docs with team training phase
</commit_message>
<xml_diff>
--- a/GeTi_CSAM_Model_Comparison_Deck.pptx
+++ b/GeTi_CSAM_Model_Comparison_Deck.pptx
@@ -10,6 +10,7 @@
     <p:sldId id="259" r:id="rId4"/>
     <p:sldId id="260" r:id="rId5"/>
     <p:sldId id="261" r:id="rId6"/>
+    <p:sldId id="262" r:id="rId7"/>
   </p:sldIdLst>
   <p:sldSz cx="12192000" cy="6858000"/>
   <p:notesSz cx="6858000" cy="9144000"/>
@@ -306,7 +307,7 @@
           <a:p>
             <a:fld id="{5BCAD085-E8A6-8845-BD4E-CB4CCA059FC4}" type="datetimeFigureOut">
               <a:rPr lang="en-US" smtClean="0"/>
-              <a:t>8/20/2026</a:t>
+              <a:t>8/24/2026</a:t>
             </a:fld>
             <a:endParaRPr lang="en-US"/>
           </a:p>
@@ -474,7 +475,7 @@
           <a:p>
             <a:fld id="{5BCAD085-E8A6-8845-BD4E-CB4CCA059FC4}" type="datetimeFigureOut">
               <a:rPr lang="en-US" smtClean="0"/>
-              <a:t>8/20/2026</a:t>
+              <a:t>8/24/2026</a:t>
             </a:fld>
             <a:endParaRPr lang="en-US"/>
           </a:p>
@@ -652,7 +653,7 @@
           <a:p>
             <a:fld id="{5BCAD085-E8A6-8845-BD4E-CB4CCA059FC4}" type="datetimeFigureOut">
               <a:rPr lang="en-US" smtClean="0"/>
-              <a:t>8/20/2026</a:t>
+              <a:t>8/24/2026</a:t>
             </a:fld>
             <a:endParaRPr lang="en-US"/>
           </a:p>
@@ -820,7 +821,7 @@
           <a:p>
             <a:fld id="{5BCAD085-E8A6-8845-BD4E-CB4CCA059FC4}" type="datetimeFigureOut">
               <a:rPr lang="en-US" smtClean="0"/>
-              <a:t>8/20/2026</a:t>
+              <a:t>8/24/2026</a:t>
             </a:fld>
             <a:endParaRPr lang="en-US"/>
           </a:p>
@@ -1065,7 +1066,7 @@
           <a:p>
             <a:fld id="{5BCAD085-E8A6-8845-BD4E-CB4CCA059FC4}" type="datetimeFigureOut">
               <a:rPr lang="en-US" smtClean="0"/>
-              <a:t>8/20/2026</a:t>
+              <a:t>8/24/2026</a:t>
             </a:fld>
             <a:endParaRPr lang="en-US"/>
           </a:p>
@@ -1350,7 +1351,7 @@
           <a:p>
             <a:fld id="{5BCAD085-E8A6-8845-BD4E-CB4CCA059FC4}" type="datetimeFigureOut">
               <a:rPr lang="en-US" smtClean="0"/>
-              <a:t>8/20/2026</a:t>
+              <a:t>8/24/2026</a:t>
             </a:fld>
             <a:endParaRPr lang="en-US"/>
           </a:p>
@@ -1769,7 +1770,7 @@
           <a:p>
             <a:fld id="{5BCAD085-E8A6-8845-BD4E-CB4CCA059FC4}" type="datetimeFigureOut">
               <a:rPr lang="en-US" smtClean="0"/>
-              <a:t>8/20/2026</a:t>
+              <a:t>8/24/2026</a:t>
             </a:fld>
             <a:endParaRPr lang="en-US"/>
           </a:p>
@@ -1886,7 +1887,7 @@
           <a:p>
             <a:fld id="{5BCAD085-E8A6-8845-BD4E-CB4CCA059FC4}" type="datetimeFigureOut">
               <a:rPr lang="en-US" smtClean="0"/>
-              <a:t>8/20/2026</a:t>
+              <a:t>8/24/2026</a:t>
             </a:fld>
             <a:endParaRPr lang="en-US"/>
           </a:p>
@@ -1981,7 +1982,7 @@
           <a:p>
             <a:fld id="{5BCAD085-E8A6-8845-BD4E-CB4CCA059FC4}" type="datetimeFigureOut">
               <a:rPr lang="en-US" smtClean="0"/>
-              <a:t>8/20/2026</a:t>
+              <a:t>8/24/2026</a:t>
             </a:fld>
             <a:endParaRPr lang="en-US"/>
           </a:p>
@@ -2256,7 +2257,7 @@
           <a:p>
             <a:fld id="{5BCAD085-E8A6-8845-BD4E-CB4CCA059FC4}" type="datetimeFigureOut">
               <a:rPr lang="en-US" smtClean="0"/>
-              <a:t>8/20/2026</a:t>
+              <a:t>8/24/2026</a:t>
             </a:fld>
             <a:endParaRPr lang="en-US"/>
           </a:p>
@@ -2508,7 +2509,7 @@
           <a:p>
             <a:fld id="{5BCAD085-E8A6-8845-BD4E-CB4CCA059FC4}" type="datetimeFigureOut">
               <a:rPr lang="en-US" smtClean="0"/>
-              <a:t>8/20/2026</a:t>
+              <a:t>8/24/2026</a:t>
             </a:fld>
             <a:endParaRPr lang="en-US"/>
           </a:p>
@@ -2719,7 +2720,7 @@
           <a:p>
             <a:fld id="{5BCAD085-E8A6-8845-BD4E-CB4CCA059FC4}" type="datetimeFigureOut">
               <a:rPr lang="en-US" smtClean="0"/>
-              <a:t>8/20/2026</a:t>
+              <a:t>8/24/2026</a:t>
             </a:fld>
             <a:endParaRPr lang="en-US"/>
           </a:p>
@@ -6645,6 +6646,209 @@
         </p:txBody>
       </p:sp>
     </p:spTree>
+  </p:cSld>
+  <p:clrMapOvr>
+    <a:masterClrMapping/>
+  </p:clrMapOvr>
+</p:sld>
+</file>
+
+<file path=ppt/slides/slide6.xml><?xml version="1.0" encoding="utf-8"?>
+<p:sld xmlns:a="http://schemas.openxmlformats.org/drawingml/2006/main" xmlns:r="http://schemas.openxmlformats.org/officeDocument/2006/relationships" xmlns:p="http://schemas.openxmlformats.org/presentationml/2006/main">
+  <p:cSld>
+    <p:spTree>
+      <p:nvGrpSpPr>
+        <p:cNvPr id="1" name="">
+          <a:extLst>
+            <a:ext uri="{FF2B5EF4-FFF2-40B4-BE49-F238E27FC236}">
+              <a16:creationId xmlns:a16="http://schemas.microsoft.com/office/drawing/2014/main" id="{64C38B47-05BE-B7D8-D598-49965ED43083}"/>
+            </a:ext>
+          </a:extLst>
+        </p:cNvPr>
+        <p:cNvGrpSpPr/>
+        <p:nvPr/>
+      </p:nvGrpSpPr>
+      <p:grpSpPr>
+        <a:xfrm>
+          <a:off x="0" y="0"/>
+          <a:ext cx="0" cy="0"/>
+          <a:chOff x="0" y="0"/>
+          <a:chExt cx="0" cy="0"/>
+        </a:xfrm>
+      </p:grpSpPr>
+      <p:sp>
+        <p:nvSpPr>
+          <p:cNvPr id="2" name="TextBox 1">
+            <a:extLst>
+              <a:ext uri="{FF2B5EF4-FFF2-40B4-BE49-F238E27FC236}">
+                <a16:creationId xmlns:a16="http://schemas.microsoft.com/office/drawing/2014/main" id="{D06C8B2F-DD09-57CA-94AA-3AE51244EBE0}"/>
+              </a:ext>
+            </a:extLst>
+          </p:cNvPr>
+          <p:cNvSpPr txBox="1"/>
+          <p:nvPr/>
+        </p:nvSpPr>
+        <p:spPr>
+          <a:xfrm>
+            <a:off x="457200" y="182880"/>
+            <a:ext cx="1794337" cy="461665"/>
+          </a:xfrm>
+          <a:prstGeom prst="rect">
+            <a:avLst/>
+          </a:prstGeom>
+          <a:noFill/>
+        </p:spPr>
+        <p:txBody>
+          <a:bodyPr wrap="none">
+            <a:spAutoFit/>
+          </a:bodyPr>
+          <a:lstStyle/>
+          <a:p>
+            <a:pPr algn="l"/>
+            <a:r>
+              <a:rPr lang="en-US" sz="2400" b="1" dirty="0">
+                <a:solidFill>
+                  <a:srgbClr val="122E4D"/>
+                </a:solidFill>
+                <a:latin typeface="Aptos"/>
+              </a:rPr>
+              <a:t>Next Steps:</a:t>
+            </a:r>
+          </a:p>
+        </p:txBody>
+      </p:sp>
+      <p:sp>
+        <p:nvSpPr>
+          <p:cNvPr id="8" name="Rectangle 7">
+            <a:extLst>
+              <a:ext uri="{FF2B5EF4-FFF2-40B4-BE49-F238E27FC236}">
+                <a16:creationId xmlns:a16="http://schemas.microsoft.com/office/drawing/2014/main" id="{A3C0E953-DBD3-AE92-9F65-2B2A35C084B2}"/>
+              </a:ext>
+            </a:extLst>
+          </p:cNvPr>
+          <p:cNvSpPr/>
+          <p:nvPr/>
+        </p:nvSpPr>
+        <p:spPr>
+          <a:xfrm>
+            <a:off x="135303" y="1280160"/>
+            <a:ext cx="11947043" cy="1368255"/>
+          </a:xfrm>
+          <a:prstGeom prst="rect">
+            <a:avLst/>
+          </a:prstGeom>
+          <a:solidFill>
+            <a:srgbClr val="FFFFFF"/>
+          </a:solidFill>
+          <a:ln w="12700">
+            <a:solidFill>
+              <a:srgbClr val="1057AE"/>
+            </a:solidFill>
+          </a:ln>
+        </p:spPr>
+        <p:style>
+          <a:lnRef idx="1">
+            <a:schemeClr val="accent1"/>
+          </a:lnRef>
+          <a:fillRef idx="3">
+            <a:schemeClr val="accent1"/>
+          </a:fillRef>
+          <a:effectRef idx="2">
+            <a:schemeClr val="accent1"/>
+          </a:effectRef>
+          <a:fontRef idx="minor">
+            <a:schemeClr val="lt1"/>
+          </a:fontRef>
+        </p:style>
+        <p:txBody>
+          <a:bodyPr wrap="square" lIns="109728" tIns="73152" rIns="109728" bIns="73152" rtlCol="0" anchor="ctr"/>
+          <a:lstStyle/>
+          <a:p>
+            <a:pPr marL="171450" indent="-171450">
+              <a:spcAft>
+                <a:spcPts val="400"/>
+              </a:spcAft>
+              <a:buFont typeface="Arial" panose="020B0604020202020204" pitchFamily="34" charset="0"/>
+              <a:buChar char="•"/>
+            </a:pPr>
+            <a:r>
+              <a:rPr lang="en-US" sz="1600" dirty="0">
+                <a:solidFill>
+                  <a:srgbClr val="122E4D"/>
+                </a:solidFill>
+                <a:latin typeface="Aptos"/>
+              </a:rPr>
+              <a:t>Finetuning the accuracy of the models for NVL (Omkar)</a:t>
+            </a:r>
+          </a:p>
+          <a:p>
+            <a:pPr marL="171450" indent="-171450">
+              <a:spcAft>
+                <a:spcPts val="400"/>
+              </a:spcAft>
+              <a:buFont typeface="Arial" panose="020B0604020202020204" pitchFamily="34" charset="0"/>
+              <a:buChar char="•"/>
+            </a:pPr>
+            <a:r>
+              <a:rPr lang="en-US" sz="1600" dirty="0">
+                <a:solidFill>
+                  <a:srgbClr val="122E4D"/>
+                </a:solidFill>
+                <a:latin typeface="Aptos"/>
+              </a:rPr>
+              <a:t>Work on Deployment of the Model for WIPs (Omkar)</a:t>
+            </a:r>
+          </a:p>
+          <a:p>
+            <a:pPr marL="171450" indent="-171450">
+              <a:spcAft>
+                <a:spcPts val="400"/>
+              </a:spcAft>
+              <a:buFont typeface="Arial" panose="020B0604020202020204" pitchFamily="34" charset="0"/>
+              <a:buChar char="•"/>
+            </a:pPr>
+            <a:r>
+              <a:rPr lang="en-US" sz="1600" dirty="0">
+                <a:solidFill>
+                  <a:srgbClr val="122E4D"/>
+                </a:solidFill>
+                <a:latin typeface="Aptos"/>
+              </a:rPr>
+              <a:t>Training for the team for Geti (Omkar)</a:t>
+            </a:r>
+          </a:p>
+          <a:p>
+            <a:pPr marL="171450" indent="-171450">
+              <a:spcAft>
+                <a:spcPts val="400"/>
+              </a:spcAft>
+              <a:buFont typeface="Arial" panose="020B0604020202020204" pitchFamily="34" charset="0"/>
+              <a:buChar char="•"/>
+            </a:pPr>
+            <a:r>
+              <a:rPr lang="en-US" sz="1600" dirty="0">
+                <a:solidFill>
+                  <a:srgbClr val="122E4D"/>
+                </a:solidFill>
+                <a:latin typeface="Aptos"/>
+              </a:rPr>
+              <a:t>Pull in team for support for other products.</a:t>
+            </a:r>
+            <a:endParaRPr sz="1600" dirty="0">
+              <a:solidFill>
+                <a:srgbClr val="122E4D"/>
+              </a:solidFill>
+              <a:latin typeface="Aptos"/>
+            </a:endParaRPr>
+          </a:p>
+        </p:txBody>
+      </p:sp>
+    </p:spTree>
+    <p:extLst>
+      <p:ext uri="{BB962C8B-B14F-4D97-AF65-F5344CB8AC3E}">
+        <p14:creationId xmlns:p14="http://schemas.microsoft.com/office/powerpoint/2010/main" val="2684706376"/>
+      </p:ext>
+    </p:extLst>
   </p:cSld>
   <p:clrMapOvr>
     <a:masterClrMapping/>

</xml_diff>